<commit_message>
Fix the two faults left in lesson 5's deck
The first was not cosmetic. Slide 32's code block calls
SelectKBest(f_classif, 10), and k has been keyword-only for several releases:
run it and you get "takes from 1 to 2 positional arguments but 3 were given".
The handout and notebook 3 both write k=10, so the deck was the only artefact
carrying it, and it is the one students copy from. All four lines now run.

Slide 36 put 0.7999, a measured maximum over 25 candidates, in the same column
as 0.5000, which is the truth by construction on data with no signal - four
decimals reading as a fourth measurement. Now "the truth, by construction" and
0.5, in the handout table too.

While checking: ten of this deck's 45 titles wrap to two lines, so slide 36 was
not unusual in that and the wrap is not what was wrong with it.

Co-Authored-By: Claude Opus 5 <noreply@anthropic.com>
Claude-Session: https://claude.ai/code/session_01AGVdtkDgZ58kt68DhqnwXC
</commit_message>
<xml_diff>
--- a/Lessons/05_experimental_methodology/Slides/experimental_methodology_slides.pptx
+++ b/Lessons/05_experimental_methodology/Slides/experimental_methodology_slides.pptx
@@ -12304,7 +12304,16 @@
               <a:rPr>
                 <a:latin typeface="Courier"/>
               </a:rPr>
-              <a:t> SelectKBest(f_classif, </a:t>
+              <a:t> SelectKBest(f_classif, k</a:t>
+            </a:r>
+            <a:r>
+              <a:rPr>
+                <a:solidFill>
+                  <a:srgbClr val="666666"/>
+                </a:solidFill>
+                <a:latin typeface="Courier"/>
+              </a:rPr>
+              <a:t>=</a:t>
             </a:r>
             <a:r>
               <a:rPr>
@@ -12893,7 +12902,7 @@
                       </a:pPr>
                       <a:r>
                         <a:rPr/>
-                        <a:t>the truth</a:t>
+                        <a:t>the truth, by construction</a:t>
                       </a:r>
                     </a:p>
                   </a:txBody>
@@ -12908,7 +12917,7 @@
                       </a:pPr>
                       <a:r>
                         <a:rPr/>
-                        <a:t>0.5000</a:t>
+                        <a:t>0.5</a:t>
                       </a:r>
                     </a:p>
                   </a:txBody>

</xml_diff>

<commit_message>
Call the rotating k-fold block a validation fold in lesson 5
Lesson 1 defines three roles - training fits, validation chooses, test
reports once - and lesson 5's own nested-CV figure labels the inner
rotating block "valid". The k-fold diagram called the same block "test",
so a student comparing the two figures met a contradiction, and learnt
to call the thing a search chooses on a test set.

The diagram, handout sections 4.1 and 7, slide notes, notebooks 1 and 3,
the quiz and the concepts index now say validation fold. Section 4.1 and
notebook 1 gain a sentence bridging to scikit-learn, whose test_index and
mean_test_score mean only "not used to fit this fold's model". The outer
test block of nested cross-validation keeps its name.

Co-Authored-By: Claude Opus 5 <noreply@anthropic.com>
</commit_message>
<xml_diff>
--- a/Lessons/05_experimental_methodology/Slides/experimental_methodology_slides.pptx
+++ b/Lessons/05_experimental_methodology/Slides/experimental_methodology_slides.pptx
@@ -679,7 +679,21 @@
             </a:pPr>
             <a:r>
               <a:rPr/>
-              <a:t>Cross-validation resolves it by rotating the role of the test block. Cut the data into k parts, train on k-1, test on the one left out, repeat until every part has been the test set exactly once.</a:t>
+              <a:t>Cross-validation resolves it by rotating which part is held out. Cut the data into k parts, train on k-1, score on the one left out - the validation fold - and repeat until every part has been the validation fold exactly once.</a:t>
+            </a:r>
+          </a:p>
+          <a:p>
+            <a:pPr lvl="0" indent="0" marL="0">
+              <a:buNone/>
+            </a:pPr>
+          </a:p>
+          <a:p>
+            <a:pPr lvl="0" indent="0" marL="0">
+              <a:buNone/>
+            </a:pPr>
+            <a:r>
+              <a:rPr/>
+              <a:t>Say why it is labelled validation and not test, because the code will contradict the slide. Lesson 1’s three roles: training fits, validation chooses, test reports once. This block is scored k times and, by the end of the lesson, is what a search chooses on. scikit-learn calls it test - test_index, mean_test_score - and there the word means only “not used to fit this fold’s model”, never the test set reported once. Handout section 4.1.</a:t>
             </a:r>
           </a:p>
           <a:p>
@@ -3515,7 +3529,7 @@
             </a:pPr>
             <a:r>
               <a:rPr/>
-              <a:t>Now the bug, which is on the first line: SelectKBest was shown EVERY row, including the rows that would later serve as test folds. It searched two thousand columns for the ones that best matched labels it had already seen, and handed the winners to cross-validation.</a:t>
+              <a:t>Now the bug, which is on the first line: SelectKBest was shown EVERY row, including the rows that would later serve as validation folds. It searched two thousand columns for the ones that best matched labels it had already seen, and handed the winners to cross-validation.</a:t>
             </a:r>
           </a:p>
           <a:p>
@@ -3749,7 +3763,7 @@
             </a:pPr>
             <a:r>
               <a:rPr/>
-              <a:t>With two thousand columns and eight hundred rows, some columns correlate with the label purely by chance across the whole dataset. That accident is a property of this particular sample. It is present in every subset of it - every training fold and every test fold alike.</a:t>
+              <a:t>With two thousand columns and eight hundred rows, some columns correlate with the label purely by chance across the whole dataset. That accident is a property of this particular sample. It is present in every subset of it - every training fold and every validation fold alike.</a:t>
             </a:r>
           </a:p>
           <a:p>

</xml_diff>

<commit_message>
Put the two means on lesson 5's seed-comparison slide
The notes tell the room that single splits and cross-validation centre in
about the same place, but the table on the slide had no mean in it, so the
claim rested on the speaker's word. Adds the row, 0.9600 against 0.9532,
as handout section 4.7 already has.

Co-Authored-By: Claude Opus 5 <noreply@anthropic.com>
</commit_message>
<xml_diff>
--- a/Lessons/05_experimental_methodology/Slides/experimental_methodology_slides.pptx
+++ b/Lessons/05_experimental_methodology/Slides/experimental_methodology_slides.pptx
@@ -9897,6 +9897,53 @@
                       <a:r>
                         <a:rPr/>
                         <a:t>0.9588</a:t>
+                      </a:r>
+                    </a:p>
+                  </a:txBody>
+                </a:tc>
+              </a:tr>
+              <a:tr h="0">
+                <a:tc>
+                  <a:txBody>
+                    <a:bodyPr/>
+                    <a:lstStyle/>
+                    <a:p>
+                      <a:pPr lvl="0" indent="0" marL="0">
+                        <a:buNone/>
+                      </a:pPr>
+                      <a:r>
+                        <a:rPr/>
+                        <a:t>mean</a:t>
+                      </a:r>
+                    </a:p>
+                  </a:txBody>
+                </a:tc>
+                <a:tc>
+                  <a:txBody>
+                    <a:bodyPr/>
+                    <a:lstStyle/>
+                    <a:p>
+                      <a:pPr lvl="0" indent="0" marL="0">
+                        <a:buNone/>
+                      </a:pPr>
+                      <a:r>
+                        <a:rPr/>
+                        <a:t>0.9600</a:t>
+                      </a:r>
+                    </a:p>
+                  </a:txBody>
+                </a:tc>
+                <a:tc>
+                  <a:txBody>
+                    <a:bodyPr/>
+                    <a:lstStyle/>
+                    <a:p>
+                      <a:pPr lvl="0" indent="0" marL="0">
+                        <a:buNone/>
+                      </a:pPr>
+                      <a:r>
+                        <a:rPr/>
+                        <a:t>0.9532</a:t>
                       </a:r>
                     </a:p>
                   </a:txBody>

</xml_diff>

<commit_message>
Get lesson 5 ready: gaps, code anchors, plain notes, and time for notebook 3
The gap audit: the switch to lesson 3's energy data is announced; bias²,
variance, the usual standard error and SelectKBest's F-test are stated; the
200-split, 40-seed and 56/19/25 procedures are on their slides; 484 is 22²;
'spread' no longer means two things; the 5-fold conditions are given; nested
cross-validation is pointed forward. Four of five leaky folds lie between
0.92 and 0.98, not 0.93 (slide and handout). Toolbox tables on the three
notebook slides and In code lines put every scikit-learn name on a slide, and
lesson 5 joins ANCHORED. Notes reread in full: degree 12 improves four
thousandfold by 60 rows, not 150. Notebook 3 gets fifteen minutes of its own.

Co-Authored-By: Claude Opus 5.5 <noreply@anthropic.com>
</commit_message>
<xml_diff>
--- a/Lessons/05_experimental_methodology/Slides/experimental_methodology_slides.pptx
+++ b/Lessons/05_experimental_methodology/Slides/experimental_methodology_slides.pptx
@@ -584,7 +584,7 @@
             </a:pPr>
             <a:r>
               <a:rPr/>
-              <a:t>The recurring mistake to name, if it appeared: choosing the threshold by sweeping it on the test set. The exercise sheet said that losing marks for it was avoidable by simply declaring it - and today is the lesson that shows why it matters rather than asserting that it does.</a:t>
+              <a:t>The recurring mistake to name, if it appeared: choosing the threshold by sweeping it on the test set. The exercise sheet said that doing so loses no marks if it is declared - and today is the lesson that shows why it matters rather than asserting that it does.</a:t>
             </a:r>
           </a:p>
         </p:txBody>
@@ -1024,7 +1024,7 @@
             </a:pPr>
             <a:r>
               <a:rPr/>
-              <a:t>The temptation is to quote s over root k and call it a confidence interval. Do not, and give them the specific reason rather than a warning.</a:t>
+              <a:t>The temptation is to quote s over root k - the standard deviation of the fold scores divided by the square root of the number of folds - and call it a confidence interval. Do not, and give them the specific reason rather than a warning.</a:t>
             </a:r>
           </a:p>
           <a:p>
@@ -1272,7 +1272,7 @@
             </a:pPr>
             <a:r>
               <a:rPr/>
-              <a:t>The spread falls from 0.0881 to 0.0149, and the standard deviation by a factor of about seven (0.0221 to 0.0032). Say which one “seven” refers to: a student who divides the two spreads on the slide gets six, and will ask.</a:t>
+              <a:t>The range, best minus worst, falls from 0.0881 to 0.0149, and the standard deviation by a factor of about seven (0.0221 to 0.0032). Say which one “seven” refers to: a student who divides the two ranges on the slide gets six, and will ask.</a:t>
             </a:r>
           </a:p>
           <a:p>
@@ -1314,7 +1314,7 @@
             </a:pPr>
             <a:r>
               <a:rPr/>
-              <a:t>What it does NOT fix is the whole last hour of today.</a:t>
+              <a:t>What it does NOT fix is the subject of slides 32 to 39.</a:t>
             </a:r>
           </a:p>
         </p:txBody>
@@ -1754,7 +1754,21 @@
             </a:pPr>
             <a:r>
               <a:rPr/>
-              <a:t>Run notebooks/01. Twenty-two minutes.</a:t>
+              <a:t>The table is the notebook’s map: each section, the calls it makes, the slides that introduced the idea, and the number to come back with.</a:t>
+            </a:r>
+          </a:p>
+          <a:p>
+            <a:pPr lvl="0" indent="0" marL="0">
+              <a:buNone/>
+            </a:pPr>
+          </a:p>
+          <a:p>
+            <a:pPr lvl="0" indent="0" marL="0">
+              <a:buNone/>
+            </a:pPr>
+            <a:r>
+              <a:rPr/>
+              <a:t>Run notebook 01. Twenty minutes.</a:t>
             </a:r>
           </a:p>
           <a:p>
@@ -1892,7 +1906,7 @@
             </a:pPr>
             <a:r>
               <a:rPr/>
-              <a:t>Section 8 of the handout pays it off, and slide 39 shows the number.</a:t>
+              <a:t>Section 8 of the handout pays it off, and slide 40 shows the number.</a:t>
             </a:r>
           </a:p>
         </p:txBody>
@@ -1974,7 +1988,7 @@
             </a:pPr>
             <a:r>
               <a:rPr/>
-              <a:t>Twelve minutes. The second half is bias-variance, which needs them awake.</a:t>
+              <a:t>Ten minutes. The second half is bias-variance, which needs them awake.</a:t>
             </a:r>
           </a:p>
         </p:txBody>
@@ -2056,7 +2070,7 @@
             </a:pPr>
             <a:r>
               <a:rPr/>
-              <a:t>Set up the decomposition in words before any algebra.</a:t>
+              <a:t>Set up the decomposition in words before any algebra, and say first that the data changes: lesson 3’s energy-against-temperature curve comes back, because here we need the true curve, and we built it ourselves. Each training set is 25 days, the noise has a standard deviation of 22 kWh, and we draw 300 such training sets.</a:t>
             </a:r>
           </a:p>
           <a:p>
@@ -2360,7 +2374,7 @@
             </a:pPr>
             <a:r>
               <a:rPr/>
-              <a:t>The important claim is that this is an IDENTITY, not an approximation or a useful metaphor. Notebook 2 checks it on 300 independently drawn training sets and the two sides agree to three times ten to the minus twelve - floating-point equality.</a:t>
+              <a:t>The important claim is that this is an IDENTITY, not an approximation or a useful metaphor. The symbols: y is a new observation, f-hat the model’s prediction for it, sigma squared the noise variance; the expectation averages over the training sets and the noise. Notebook 2 checks it on 300 independently drawn training sets and the two sides agree to 2.7 times ten to the minus twelve - floating-point equality.</a:t>
             </a:r>
           </a:p>
           <a:p>
@@ -2856,7 +2870,7 @@
             </a:pPr>
             <a:r>
               <a:rPr/>
-              <a:t>Degree 12 improves by a factor of four thousand between 25 and 150 observations and is still the worst model in its column.</a:t>
+              <a:t>Degree 12 improves by a factor of four thousand between 25 and 60 observations, and of thirty-six thousand by 150, and is still the worst model in its column.</a:t>
             </a:r>
           </a:p>
           <a:p>
@@ -2980,7 +2994,7 @@
             </a:pPr>
             <a:r>
               <a:rPr/>
-              <a:t>Train on 15% of the data, then 25%, and so on, plotting training score and cross-validated score against the number of examples used.</a:t>
+              <a:t>Train on 15% of each training fold, then on larger shares, eight sizes up to all of it, plotting training score and cross-validated score against the number of examples used. The data is the 800 drives again; the first bullet of the next slide names the scikit-learn call that does it.</a:t>
             </a:r>
           </a:p>
           <a:p>
@@ -3022,7 +3036,7 @@
             </a:pPr>
             <a:r>
               <a:rPr/>
-              <a:t>Then read the right-hand curve to the end, because this is where the room gets it wrong - and so did this deck until someone read the numbers. It climbs to 0.857 at 251 examples and then stops: 0.834, 0.847, 0.835, 0.832, 0.847. It ends below its own high point.</a:t>
+              <a:t>Then read the right-hand curve to the end, because this is where the room gets it wrong. It climbs to 0.857 at 251 examples and then stops: 0.834, 0.847, 0.835, 0.832, 0.847. It ends below its own high point.</a:t>
             </a:r>
           </a:p>
           <a:p>
@@ -3380,7 +3394,7 @@
             </a:pPr>
             <a:r>
               <a:rPr/>
-              <a:t>Run notebooks/02. Twenty minutes.</a:t>
+              <a:t>The table maps each section to its calls and its number. Run notebook 02. Twenty minutes.</a:t>
             </a:r>
           </a:p>
           <a:p>
@@ -3521,6 +3535,20 @@
               <a:t>Tell them what is coming so they can watch for it: we are going to write code that looks completely reasonable, and get 0.93.</a:t>
             </a:r>
           </a:p>
+          <a:p>
+            <a:pPr lvl="0" indent="0" marL="0">
+              <a:buNone/>
+            </a:pPr>
+          </a:p>
+          <a:p>
+            <a:pPr lvl="0" indent="0" marL="0">
+              <a:buNone/>
+            </a:pPr>
+            <a:r>
+              <a:rPr/>
+              <a:t>The last bullet names the selector. f_classif scores each column by how far apart its means are for the two classes, relative to its spread (an analysis-of-variance F-test), and SelectKBest keeps the k best. Point out the clash of letters: this k counts columns, not folds.</a:t>
+            </a:r>
+          </a:p>
         </p:txBody>
       </p:sp>
       <p:sp>
@@ -3614,7 +3642,7 @@
             </a:pPr>
             <a:r>
               <a:rPr/>
-              <a:t>Every line is defensible in isolation. Feature selection is normal. Ten from two thousand is reasonable. Cross-validating afterwards is exactly what we spent the morning recommending.</a:t>
+              <a:t>Every line is defensible in isolation. Feature selection is normal. Ten from two thousand is reasonable. Cross-validating afterwards is exactly what the first half of today recommended.</a:t>
             </a:r>
           </a:p>
           <a:p>
@@ -3710,7 +3738,7 @@
             </a:pPr>
             <a:r>
               <a:rPr/>
-              <a:t>The result. Tight fold agreement, which is exactly what a trustworthy result looks like.</a:t>
+              <a:t>The result. The folds are 0.928, 0.979, 0.975, 0.943 and 0.832: close agreement, which is exactly what a trustworthy result looks like.</a:t>
             </a:r>
           </a:p>
           <a:p>
@@ -4082,7 +4110,7 @@
             </a:pPr>
             <a:r>
               <a:rPr/>
-              <a:t>Choosing between configurations is choosing, and choosing on data costs the same honesty. Twenty-five combinations on the same signal-free table.</a:t>
+              <a:t>Choosing between configurations is choosing, and choosing on data costs the same honesty. GridSearchCV tries every combination of five values of k (columns kept) and five of C, 25 in all, each scored by 5-fold cross-validation, on the same signal-free table. The nested row is explained on the next slide; read the first two rows now.</a:t>
             </a:r>
           </a:p>
           <a:p>
@@ -4454,7 +4482,7 @@
             </a:pPr>
             <a:r>
               <a:rPr/>
-              <a:t>Lesson 4’s threshold, done properly. Split three ways: train to fit, validation to choose, test to report once.</a:t>
+              <a:t>Lesson 4’s threshold, done properly. Split three ways, as the table header says: fit on 56%, choose the threshold on 19%, report once on the remaining 25%.</a:t>
             </a:r>
           </a:p>
           <a:p>
@@ -4936,7 +4964,7 @@
             </a:pPr>
             <a:r>
               <a:rPr/>
-              <a:t>Practical checklist. The container exists for the second item: it pins the environment so that their result and the marker’s result are the same result.</a:t>
+              <a:t>Practical checklist. The container exists for the second item: it pins the environment so that their result and the examiner’s are the same result.</a:t>
             </a:r>
           </a:p>
           <a:p>
@@ -5046,7 +5074,7 @@
             </a:pPr>
             <a:r>
               <a:rPr/>
-              <a:t>Run notebooks/03. Twenty minutes if the clock allows.</a:t>
+              <a:t>The table pairs each section with its calls and its number. Run notebook 03. Fifteen minutes.</a:t>
             </a:r>
           </a:p>
           <a:p>
@@ -5486,6 +5514,20 @@
             </a:pPr>
             <a:r>
               <a:rPr/>
+              <a:t>The model is lesson 4’s, unchanged: scaled features, logistic regression, scored by AUC on a stratified 75/25 split - the In code line names each piece.</a:t>
+            </a:r>
+          </a:p>
+          <a:p>
+            <a:pPr lvl="0" indent="0" marL="0">
+              <a:buNone/>
+            </a:pPr>
+          </a:p>
+          <a:p>
+            <a:pPr lvl="0" indent="0" marL="0">
+              <a:buNone/>
+            </a:pPr>
+            <a:r>
+              <a:rPr/>
               <a:t>Justify the reduction explicitly, because a sharp student will otherwise suspect the demonstration is rigged.</a:t>
             </a:r>
           </a:p>
@@ -6010,7 +6052,21 @@
             </a:pPr>
             <a:r>
               <a:rPr/>
-              <a:t>Read the first column, then the last. The three models are the SAME: their mean performance agrees to three decimal places, a difference an order of magnitude smaller than the spread of a single measurement.</a:t>
+              <a:t>Say what was done first, since the title only hints at it: 200 splits, the three models scored on each, and on each split the one with the highest AUC declared best.</a:t>
+            </a:r>
+          </a:p>
+          <a:p>
+            <a:pPr lvl="0" indent="0" marL="0">
+              <a:buNone/>
+            </a:pPr>
+          </a:p>
+          <a:p>
+            <a:pPr lvl="0" indent="0" marL="0">
+              <a:buNone/>
+            </a:pPr>
+            <a:r>
+              <a:rPr/>
+              <a:t>Read the first column, then the last. The three models are the SAME: their mean AUCs differ by at most 0.0005, about fifty times less than the standard deviation of a single measurement, 0.024.</a:t>
             </a:r>
           </a:p>
           <a:p>
@@ -9229,7 +9285,7 @@
             </a:pPr>
             <a:r>
               <a:rPr/>
-              <a:t>Now the expensive part: choosing</a:t>
+              <a:t>Now the expensive part: choosing, on each of 200 splits</a:t>
             </a:r>
           </a:p>
         </p:txBody>
@@ -9270,7 +9326,7 @@
                       </a:pPr>
                       <a:r>
                         <a:rPr/>
-                        <a:t>Model</a:t>
+                        <a:t>Three models</a:t>
                       </a:r>
                     </a:p>
                   </a:txBody>
@@ -9302,7 +9358,7 @@
                       </a:pPr>
                       <a:r>
                         <a:rPr/>
-                        <a:t>Times declared best</a:t>
+                        <a:t>Times it scored highest</a:t>
                       </a:r>
                     </a:p>
                   </a:txBody>
@@ -9716,7 +9772,24 @@
             </a:r>
             <a:r>
               <a:rPr/>
-              <a:t>: each fold trains on 80% of the data</a:t>
+              <a:t>: with 5 folds, each model trains on 80% of the data</a:t>
+            </a:r>
+          </a:p>
+          <a:p>
+            <a:pPr lvl="0"/>
+            <a:r>
+              <a:rPr/>
+              <a:t>In code: </a:t>
+            </a:r>
+            <a:r>
+              <a:rPr>
+                <a:latin typeface="Courier"/>
+              </a:rPr>
+              <a:t>cross_val_score(model, X, y, cv=StratifiedKFold(5, shuffle=True),   scoring="roc_auc")</a:t>
+            </a:r>
+            <a:r>
+              <a:rPr/>
+              <a:t>, one score per fold</a:t>
             </a:r>
           </a:p>
         </p:txBody>
@@ -9796,7 +9869,7 @@
             <a:pPr lvl="0"/>
             <a:r>
               <a:rPr/>
-              <a:t>Any two training folds share </a:t>
+              <a:t>With 5 folds, any two training sets share </a:t>
             </a:r>
             <a:r>
               <a:rPr b="1"/>
@@ -9811,7 +9884,7 @@
             <a:pPr lvl="0"/>
             <a:r>
               <a:rPr/>
-              <a:t>The scores are correlated, so the usual standard error is optimistic</a:t>
+              <a:t>The scores are correlated, so the usual standard error, s ÷ √k (s the standard deviation of the k fold scores), is optimistic</a:t>
             </a:r>
           </a:p>
         </p:txBody>
@@ -10265,7 +10338,13 @@
                     <a:bodyPr/>
                     <a:lstStyle/>
                     <a:p>
-                      <a:endParaRPr/>
+                      <a:pPr lvl="0" indent="0" marL="0">
+                        <a:buNone/>
+                      </a:pPr>
+                      <a:r>
+                        <a:rPr/>
+                        <a:t>Over 40 seeds</a:t>
+                      </a:r>
                     </a:p>
                   </a:txBody>
                   <a:tcPr/>
@@ -10296,7 +10375,7 @@
                       </a:pPr>
                       <a:r>
                         <a:rPr/>
-                        <a:t>5-fold CV</a:t>
+                        <a:t>5-fold cross-validation</a:t>
                       </a:r>
                     </a:p>
                   </a:txBody>
@@ -10455,7 +10534,7 @@
                       </a:pPr>
                       <a:r>
                         <a:rPr/>
-                        <a:t>spread</a:t>
+                        <a:t>best − worst</a:t>
                       </a:r>
                     </a:p>
                   </a:txBody>
@@ -10933,34 +11012,286 @@
           </a:p>
         </p:txBody>
       </p:sp>
-      <p:sp>
-        <p:nvSpPr>
-          <p:cNvPr id="3" name="Content Placeholder 2"/>
-          <p:cNvSpPr>
-            <a:spLocks noGrp="1"/>
-          </p:cNvSpPr>
+      <p:graphicFrame>
+        <p:nvGraphicFramePr>
+          <p:cNvPr id="6" name="Content Placeholder 5"/>
+          <p:cNvGraphicFramePr>
+            <a:graphicFrameLocks noGrp="1"/>
+          </p:cNvGraphicFramePr>
           <p:nvPr>
             <p:ph idx="1"/>
           </p:nvPr>
-        </p:nvSpPr>
-        <p:spPr>
-          <a:xfrm>
-            <a:off x="457200" y="1200151"/>
-            <a:ext cx="8229600" cy="3394472"/>
-          </a:xfrm>
-        </p:spPr>
-        <p:txBody>
-          <a:bodyPr/>
-          <a:lstStyle/>
-          <a:p>
-            <a:pPr lvl="0"/>
-            <a:r>
-              <a:rPr/>
-              <a:t>The split lottery, the three identical models, k-fold by hand</a:t>
-            </a:r>
-          </a:p>
-        </p:txBody>
-      </p:sp>
+        </p:nvGraphicFramePr>
+        <p:xfrm>
+          <a:off x="457200" y="1166099"/>
+          <a:ext cx="8229600" cy="3390900"/>
+        </p:xfrm>
+        <a:graphic>
+          <a:graphicData uri="http://schemas.openxmlformats.org/drawingml/2006/table">
+            <a:tbl>
+              <a:tblPr firstRow="1" bandRow="1">
+                <a:tableStyleId>{5C22544A-7EE6-4342-B048-85BDC9FD1C3A}</a:tableStyleId>
+              </a:tblPr>
+              <a:tblGrid>
+                <a:gridCol w="4114800"/>
+                <a:gridCol w="4114800"/>
+              </a:tblGrid>
+              <a:tr h="0">
+                <a:tc>
+                  <a:txBody>
+                    <a:bodyPr/>
+                    <a:lstStyle/>
+                    <a:p>
+                      <a:pPr lvl="0" indent="0" marL="0">
+                        <a:buNone/>
+                      </a:pPr>
+                      <a:r>
+                        <a:rPr/>
+                        <a:t>section, and its slides</a:t>
+                      </a:r>
+                    </a:p>
+                  </a:txBody>
+                  <a:tcPr/>
+                </a:tc>
+                <a:tc>
+                  <a:txBody>
+                    <a:bodyPr/>
+                    <a:lstStyle/>
+                    <a:p>
+                      <a:pPr lvl="0" indent="0" marL="0">
+                        <a:buNone/>
+                      </a:pPr>
+                      <a:r>
+                        <a:rPr/>
+                        <a:t>you call (→ the number to come back with)</a:t>
+                      </a:r>
+                    </a:p>
+                  </a:txBody>
+                  <a:tcPr/>
+                </a:tc>
+              </a:tr>
+              <a:tr h="0">
+                <a:tc>
+                  <a:txBody>
+                    <a:bodyPr/>
+                    <a:lstStyle/>
+                    <a:p>
+                      <a:pPr lvl="0" indent="0" marL="0">
+                        <a:buNone/>
+                      </a:pPr>
+                      <a:r>
+                        <a:rPr/>
+                        <a:t>two honest experiments, 5-6</a:t>
+                      </a:r>
+                    </a:p>
+                  </a:txBody>
+                </a:tc>
+                <a:tc>
+                  <a:txBody>
+                    <a:bodyPr/>
+                    <a:lstStyle/>
+                    <a:p>
+                      <a:pPr lvl="0" indent="0" marL="0">
+                        <a:buNone/>
+                      </a:pPr>
+                      <a:r>
+                        <a:rPr>
+                          <a:latin typeface="Courier"/>
+                        </a:rPr>
+                        <a:t>train_test_split(..., random_state=seed)</a:t>
+                      </a:r>
+                      <a:r>
+                        <a:rPr/>
+                        <a:t>, </a:t>
+                      </a:r>
+                      <a:r>
+                        <a:rPr>
+                          <a:latin typeface="Courier"/>
+                        </a:rPr>
+                        <a:t>make_pipeline(StandardScaler(), LogisticRegression())</a:t>
+                      </a:r>
+                      <a:r>
+                        <a:rPr/>
+                        <a:t>, </a:t>
+                      </a:r>
+                      <a:r>
+                        <a:rPr>
+                          <a:latin typeface="Courier"/>
+                        </a:rPr>
+                        <a:t>roc_auc_score</a:t>
+                      </a:r>
+                      <a:r>
+                        <a:rPr/>
+                        <a:t> → seed 3 gives 1.000</a:t>
+                      </a:r>
+                    </a:p>
+                  </a:txBody>
+                </a:tc>
+              </a:tr>
+              <a:tr h="0">
+                <a:tc>
+                  <a:txBody>
+                    <a:bodyPr/>
+                    <a:lstStyle/>
+                    <a:p>
+                      <a:pPr lvl="0" indent="0" marL="0">
+                        <a:buNone/>
+                      </a:pPr>
+                      <a:r>
+                        <a:rPr/>
+                        <a:t>how wide, 7-8</a:t>
+                      </a:r>
+                    </a:p>
+                  </a:txBody>
+                </a:tc>
+                <a:tc>
+                  <a:txBody>
+                    <a:bodyPr/>
+                    <a:lstStyle/>
+                    <a:p>
+                      <a:pPr lvl="0" indent="0" marL="0">
+                        <a:buNone/>
+                      </a:pPr>
+                      <a:r>
+                        <a:rPr/>
+                        <a:t>the same, 200 times → 0.885 to 1.000</a:t>
+                      </a:r>
+                    </a:p>
+                  </a:txBody>
+                </a:tc>
+              </a:tr>
+              <a:tr h="0">
+                <a:tc>
+                  <a:txBody>
+                    <a:bodyPr/>
+                    <a:lstStyle/>
+                    <a:p>
+                      <a:pPr lvl="0" indent="0" marL="0">
+                        <a:buNone/>
+                      </a:pPr>
+                      <a:r>
+                        <a:rPr/>
+                        <a:t>choosing on one split, 9-11</a:t>
+                      </a:r>
+                    </a:p>
+                  </a:txBody>
+                </a:tc>
+                <a:tc>
+                  <a:txBody>
+                    <a:bodyPr/>
+                    <a:lstStyle/>
+                    <a:p>
+                      <a:pPr lvl="0" indent="0" marL="0">
+                        <a:buNone/>
+                      </a:pPr>
+                      <a:r>
+                        <a:rPr/>
+                        <a:t>three values of C, a winner per split → 91, 71 and 38 wins</a:t>
+                      </a:r>
+                    </a:p>
+                  </a:txBody>
+                </a:tc>
+              </a:tr>
+              <a:tr h="0">
+                <a:tc>
+                  <a:txBody>
+                    <a:bodyPr/>
+                    <a:lstStyle/>
+                    <a:p>
+                      <a:pPr lvl="0" indent="0" marL="0">
+                        <a:buNone/>
+                      </a:pPr>
+                      <a:r>
+                        <a:rPr/>
+                        <a:t>k-fold by hand, 12-14</a:t>
+                      </a:r>
+                    </a:p>
+                  </a:txBody>
+                </a:tc>
+                <a:tc>
+                  <a:txBody>
+                    <a:bodyPr/>
+                    <a:lstStyle/>
+                    <a:p>
+                      <a:pPr lvl="0" indent="0" marL="0">
+                        <a:buNone/>
+                      </a:pPr>
+                      <a:r>
+                        <a:rPr>
+                          <a:latin typeface="Courier"/>
+                        </a:rPr>
+                        <a:t>StratifiedKFold</a:t>
+                      </a:r>
+                      <a:r>
+                        <a:rPr/>
+                        <a:t>, then </a:t>
+                      </a:r>
+                      <a:r>
+                        <a:rPr>
+                          <a:latin typeface="Courier"/>
+                        </a:rPr>
+                        <a:t>cross_val_score</a:t>
+                      </a:r>
+                      <a:r>
+                        <a:rPr/>
+                        <a:t> → 0.9514 ± 0.0187, identical</a:t>
+                      </a:r>
+                    </a:p>
+                  </a:txBody>
+                </a:tc>
+              </a:tr>
+              <a:tr h="0">
+                <a:tc>
+                  <a:txBody>
+                    <a:bodyPr/>
+                    <a:lstStyle/>
+                    <a:p>
+                      <a:pPr lvl="0" indent="0" marL="0">
+                        <a:buNone/>
+                      </a:pPr>
+                      <a:r>
+                        <a:rPr/>
+                        <a:t>stratify, 15-16</a:t>
+                      </a:r>
+                    </a:p>
+                  </a:txBody>
+                </a:tc>
+                <a:tc>
+                  <a:txBody>
+                    <a:bodyPr/>
+                    <a:lstStyle/>
+                    <a:p>
+                      <a:pPr lvl="0" indent="0" marL="0">
+                        <a:buNone/>
+                      </a:pPr>
+                      <a:r>
+                        <a:rPr>
+                          <a:latin typeface="Courier"/>
+                        </a:rPr>
+                        <a:t>KFold</a:t>
+                      </a:r>
+                      <a:r>
+                        <a:rPr/>
+                        <a:t> against </a:t>
+                      </a:r>
+                      <a:r>
+                        <a:rPr>
+                          <a:latin typeface="Courier"/>
+                        </a:rPr>
+                        <a:t>StratifiedKFold</a:t>
+                      </a:r>
+                      <a:r>
+                        <a:rPr/>
+                        <a:t> → a fold with 1 failure; best − worst 0.0881 against 0.0149</a:t>
+                      </a:r>
+                    </a:p>
+                  </a:txBody>
+                </a:tc>
+              </a:tr>
+            </a:tbl>
+          </a:graphicData>
+        </a:graphic>
+      </p:graphicFrame>
     </p:spTree>
   </p:cSld>
 </p:sld>
@@ -11036,7 +11367,7 @@
             <a:pPr lvl="0"/>
             <a:r>
               <a:rPr/>
-              <a:t>Twelve minutes</a:t>
+              <a:t>Ten minutes</a:t>
             </a:r>
           </a:p>
         </p:txBody>
@@ -11116,11 +11447,11 @@
             <a:pPr lvl="0"/>
             <a:r>
               <a:rPr b="1"/>
-              <a:t>Bias</a:t>
-            </a:r>
-            <a:r>
-              <a:rPr/>
-              <a:t>: the average model is wrong</a:t>
+              <a:t>Bias²</a:t>
+            </a:r>
+            <a:r>
+              <a:rPr/>
+              <a:t>: (average prediction − truth)²: the average model is wrong</a:t>
             </a:r>
           </a:p>
           <a:p>
@@ -11131,7 +11462,7 @@
             </a:r>
             <a:r>
               <a:rPr/>
-              <a:t>: the individual models disagree</a:t>
+              <a:t>: the spread of the models around their average</a:t>
             </a:r>
           </a:p>
           <a:p>
@@ -11142,7 +11473,20 @@
             </a:r>
             <a:r>
               <a:rPr/>
-              <a:t>: the target itself is uncertain</a:t>
+              <a:t> σ²: the target itself is uncertain</a:t>
+            </a:r>
+          </a:p>
+          <a:p>
+            <a:pPr lvl="0"/>
+            <a:r>
+              <a:rPr/>
+              <a:t>Lesson 3’s energy curve, 300 training sets of 25 days, each fitted with </a:t>
+            </a:r>
+            <a:r>
+              <a:rPr>
+                <a:latin typeface="Courier"/>
+              </a:rPr>
+              <a:t>make_pipeline(PolynomialFeatures(degree), LinearRegression())</a:t>
             </a:r>
           </a:p>
         </p:txBody>
@@ -11949,14 +12293,14 @@
             </a:r>
             <a:r>
               <a:rPr/>
-              <a:t> at every complexity</a:t>
+              <a:t> = 22², the noise put into the data, at every complexity</a:t>
             </a:r>
           </a:p>
           <a:p>
             <a:pPr lvl="0"/>
             <a:r>
               <a:rPr/>
-              <a:t>A reported error below the floor means </a:t>
+              <a:t>A reported error well below a known floor means </a:t>
             </a:r>
             <a:r>
               <a:rPr b="1"/>
@@ -12558,6 +12902,19 @@
             <a:pPr lvl="0"/>
             <a:r>
               <a:rPr/>
+              <a:t>A learning curve: training and cross-validated score against training-set size, </a:t>
+            </a:r>
+            <a:r>
+              <a:rPr>
+                <a:latin typeface="Courier"/>
+              </a:rPr>
+              <a:t>learning_curve(model, X, y, cv=folds, scoring="roc_auc")</a:t>
+            </a:r>
+          </a:p>
+          <a:p>
+            <a:pPr lvl="0"/>
+            <a:r>
+              <a:rPr/>
               <a:t>Curves </a:t>
             </a:r>
             <a:r>
@@ -12669,34 +13026,238 @@
           </a:p>
         </p:txBody>
       </p:sp>
-      <p:sp>
-        <p:nvSpPr>
-          <p:cNvPr id="3" name="Content Placeholder 2"/>
-          <p:cNvSpPr>
-            <a:spLocks noGrp="1"/>
-          </p:cNvSpPr>
+      <p:graphicFrame>
+        <p:nvGraphicFramePr>
+          <p:cNvPr id="6" name="Content Placeholder 5"/>
+          <p:cNvGraphicFramePr>
+            <a:graphicFrameLocks noGrp="1"/>
+          </p:cNvGraphicFramePr>
           <p:nvPr>
             <p:ph idx="1"/>
           </p:nvPr>
-        </p:nvSpPr>
-        <p:spPr>
-          <a:xfrm>
-            <a:off x="457200" y="1200151"/>
-            <a:ext cx="8229600" cy="3394472"/>
-          </a:xfrm>
-        </p:spPr>
-        <p:txBody>
-          <a:bodyPr/>
-          <a:lstStyle/>
-          <a:p>
-            <a:pPr lvl="0"/>
-            <a:r>
-              <a:rPr/>
-              <a:t>Measuring bias and variance; the learning curves</a:t>
-            </a:r>
-          </a:p>
-        </p:txBody>
-      </p:sp>
+        </p:nvGraphicFramePr>
+        <p:xfrm>
+          <a:off x="457200" y="1166099"/>
+          <a:ext cx="8229600" cy="3390900"/>
+        </p:xfrm>
+        <a:graphic>
+          <a:graphicData uri="http://schemas.openxmlformats.org/drawingml/2006/table">
+            <a:tbl>
+              <a:tblPr firstRow="1" bandRow="1">
+                <a:tableStyleId>{5C22544A-7EE6-4342-B048-85BDC9FD1C3A}</a:tableStyleId>
+              </a:tblPr>
+              <a:tblGrid>
+                <a:gridCol w="4114800"/>
+                <a:gridCol w="4114800"/>
+              </a:tblGrid>
+              <a:tr h="0">
+                <a:tc>
+                  <a:txBody>
+                    <a:bodyPr/>
+                    <a:lstStyle/>
+                    <a:p>
+                      <a:pPr lvl="0" indent="0" marL="0">
+                        <a:buNone/>
+                      </a:pPr>
+                      <a:r>
+                        <a:rPr/>
+                        <a:t>section, and its slides</a:t>
+                      </a:r>
+                    </a:p>
+                  </a:txBody>
+                  <a:tcPr/>
+                </a:tc>
+                <a:tc>
+                  <a:txBody>
+                    <a:bodyPr/>
+                    <a:lstStyle/>
+                    <a:p>
+                      <a:pPr lvl="0" indent="0" marL="0">
+                        <a:buNone/>
+                      </a:pPr>
+                      <a:r>
+                        <a:rPr/>
+                        <a:t>you call (→ the number to come back with)</a:t>
+                      </a:r>
+                    </a:p>
+                  </a:txBody>
+                  <a:tcPr/>
+                </a:tc>
+              </a:tr>
+              <a:tr h="0">
+                <a:tc>
+                  <a:txBody>
+                    <a:bodyPr/>
+                    <a:lstStyle/>
+                    <a:p>
+                      <a:pPr lvl="0" indent="0" marL="0">
+                        <a:buNone/>
+                      </a:pPr>
+                      <a:r>
+                        <a:rPr/>
+                        <a:t>300 parallel universes, 22-23</a:t>
+                      </a:r>
+                    </a:p>
+                  </a:txBody>
+                </a:tc>
+                <a:tc>
+                  <a:txBody>
+                    <a:bodyPr/>
+                    <a:lstStyle/>
+                    <a:p>
+                      <a:pPr lvl="0" indent="0" marL="0">
+                        <a:buNone/>
+                      </a:pPr>
+                      <a:r>
+                        <a:rPr>
+                          <a:latin typeface="Courier"/>
+                        </a:rPr>
+                        <a:t>PolynomialFeatures</a:t>
+                      </a:r>
+                      <a:r>
+                        <a:rPr/>
+                        <a:t> then </a:t>
+                      </a:r>
+                      <a:r>
+                        <a:rPr>
+                          <a:latin typeface="Courier"/>
+                        </a:rPr>
+                        <a:t>LinearRegression</a:t>
+                      </a:r>
+                      <a:r>
+                        <a:rPr/>
+                        <a:t>, in </a:t>
+                      </a:r>
+                      <a:r>
+                        <a:rPr>
+                          <a:latin typeface="Courier"/>
+                        </a:rPr>
+                        <a:t>make_pipeline</a:t>
+                      </a:r>
+                      <a:r>
+                        <a:rPr/>
+                        <a:t>, fitted 300 times</a:t>
+                      </a:r>
+                    </a:p>
+                  </a:txBody>
+                </a:tc>
+              </a:tr>
+              <a:tr h="0">
+                <a:tc>
+                  <a:txBody>
+                    <a:bodyPr/>
+                    <a:lstStyle/>
+                    <a:p>
+                      <a:pPr lvl="0" indent="0" marL="0">
+                        <a:buNone/>
+                      </a:pPr>
+                      <a:r>
+                        <a:rPr/>
+                        <a:t>the three parts measured, 24-27</a:t>
+                      </a:r>
+                    </a:p>
+                  </a:txBody>
+                </a:tc>
+                <a:tc>
+                  <a:txBody>
+                    <a:bodyPr/>
+                    <a:lstStyle/>
+                    <a:p>
+                      <a:pPr lvl="0" indent="0" marL="0">
+                        <a:buNone/>
+                      </a:pPr>
+                      <a:r>
+                        <a:rPr/>
+                        <a:t>NumPy on the 300 predictions → sum and measured error agree to 2.73e-12</a:t>
+                      </a:r>
+                    </a:p>
+                  </a:txBody>
+                </a:tc>
+              </a:tr>
+              <a:tr h="0">
+                <a:tc>
+                  <a:txBody>
+                    <a:bodyPr/>
+                    <a:lstStyle/>
+                    <a:p>
+                      <a:pPr lvl="0" indent="0" marL="0">
+                        <a:buNone/>
+                      </a:pPr>
+                      <a:r>
+                        <a:rPr/>
+                        <a:t>more data moves the answer, 28</a:t>
+                      </a:r>
+                    </a:p>
+                  </a:txBody>
+                </a:tc>
+                <a:tc>
+                  <a:txBody>
+                    <a:bodyPr/>
+                    <a:lstStyle/>
+                    <a:p>
+                      <a:pPr lvl="0" indent="0" marL="0">
+                        <a:buNone/>
+                      </a:pPr>
+                      <a:r>
+                        <a:rPr/>
+                        <a:t>the same at 25, 60 and 150 days → best degree 2, then 5</a:t>
+                      </a:r>
+                    </a:p>
+                  </a:txBody>
+                </a:tc>
+              </a:tr>
+              <a:tr h="0">
+                <a:tc>
+                  <a:txBody>
+                    <a:bodyPr/>
+                    <a:lstStyle/>
+                    <a:p>
+                      <a:pPr lvl="0" indent="0" marL="0">
+                        <a:buNone/>
+                      </a:pPr>
+                      <a:r>
+                        <a:rPr/>
+                        <a:t>learning curves, 29-30</a:t>
+                      </a:r>
+                    </a:p>
+                  </a:txBody>
+                </a:tc>
+                <a:tc>
+                  <a:txBody>
+                    <a:bodyPr/>
+                    <a:lstStyle/>
+                    <a:p>
+                      <a:pPr lvl="0" indent="0" marL="0">
+                        <a:buNone/>
+                      </a:pPr>
+                      <a:r>
+                        <a:rPr>
+                          <a:latin typeface="Courier"/>
+                        </a:rPr>
+                        <a:t>learning_curve</a:t>
+                      </a:r>
+                      <a:r>
+                        <a:rPr/>
+                        <a:t> with </a:t>
+                      </a:r>
+                      <a:r>
+                        <a:rPr>
+                          <a:latin typeface="Courier"/>
+                        </a:rPr>
+                        <a:t>StratifiedKFold</a:t>
+                      </a:r>
+                      <a:r>
+                        <a:rPr/>
+                        <a:t> → 0.715 against 0.718; 1.000 against 0.847</a:t>
+                      </a:r>
+                    </a:p>
+                  </a:txBody>
+                </a:tc>
+              </a:tr>
+            </a:tbl>
+          </a:graphicData>
+        </a:graphic>
+      </p:graphicFrame>
     </p:spTree>
   </p:cSld>
 </p:sld>
@@ -12778,6 +13339,10 @@
               <a:rPr b="1"/>
               <a:t>pure random noise</a:t>
             </a:r>
+            <a:r>
+              <a:rPr/>
+              <a:t>, 800 rows, 29 positives</a:t>
+            </a:r>
           </a:p>
           <a:p>
             <a:pPr lvl="0"/>
@@ -12795,6 +13360,23 @@
             <a:r>
               <a:rPr b="1"/>
               <a:t>0.500</a:t>
+            </a:r>
+          </a:p>
+          <a:p>
+            <a:pPr lvl="0"/>
+            <a:r>
+              <a:rPr/>
+              <a:t>The plan: keep the 10 columns whose F-test against the label scores highest, </a:t>
+            </a:r>
+            <a:r>
+              <a:rPr>
+                <a:latin typeface="Courier"/>
+              </a:rPr>
+              <a:t>SelectKBest(f_classif, k=10)</a:t>
+            </a:r>
+            <a:r>
+              <a:rPr/>
+              <a:t>, then cross-validate</a:t>
             </a:r>
           </a:p>
         </p:txBody>
@@ -13063,7 +13645,7 @@
             <a:pPr lvl="0"/>
             <a:r>
               <a:rPr/>
-              <a:t>Four of five folds between 0.93 and 0.98</a:t>
+              <a:t>Four of five folds between 0.92 and 0.98</a:t>
             </a:r>
           </a:p>
         </p:txBody>
@@ -13151,7 +13733,13 @@
             </a:r>
             <a:r>
               <a:rPr/>
-              <a:t> the pipeline, refitted per fold</a:t>
+              <a:t> the pipeline, refitted per fold: </a:t>
+            </a:r>
+            <a:r>
+              <a:rPr>
+                <a:latin typeface="Courier"/>
+              </a:rPr>
+              <a:t>Pipeline([("select", SelectKBest(f_classif, k=10)), ("scale", ...), ("model", ...)])</a:t>
             </a:r>
           </a:p>
           <a:p>
@@ -13163,6 +13751,10 @@
             <a:r>
               <a:rPr b="1"/>
               <a:t>0.658</a:t>
+            </a:r>
+            <a:r>
+              <a:rPr/>
+              <a:t> on average, 0.576 to 0.759</a:t>
             </a:r>
           </a:p>
           <a:p>
@@ -13362,7 +13954,19 @@
                     <a:bodyPr/>
                     <a:lstStyle/>
                     <a:p>
-                      <a:endParaRPr/>
+                      <a:pPr lvl="0" indent="0" marL="0">
+                        <a:buNone/>
+                      </a:pPr>
+                      <a:r>
+                        <a:rPr>
+                          <a:latin typeface="Courier"/>
+                        </a:rPr>
+                        <a:t>GridSearchCV</a:t>
+                      </a:r>
+                      <a:r>
+                        <a:rPr/>
+                        <a:t>, 5 values of k × 5 of C</a:t>
+                      </a:r>
                     </a:p>
                   </a:txBody>
                   <a:tcPr/>
@@ -13395,7 +13999,13 @@
                       </a:pPr>
                       <a:r>
                         <a:rPr/>
-                        <a:t>best of 25 candidates</a:t>
+                        <a:t>best of 25 candidates, </a:t>
+                      </a:r>
+                      <a:r>
+                        <a:rPr>
+                          <a:latin typeface="Courier"/>
+                        </a:rPr>
+                        <a:t>best_score_</a:t>
                       </a:r>
                     </a:p>
                   </a:txBody>
@@ -13459,7 +14069,7 @@
                       </a:pPr>
                       <a:r>
                         <a:rPr/>
-                        <a:t>nested cross-validation</a:t>
+                        <a:t>nested cross-validation, next slide</a:t>
                       </a:r>
                     </a:p>
                   </a:txBody>
@@ -13875,7 +14485,7 @@
                       </a:pPr>
                       <a:r>
                         <a:rPr/>
-                        <a:t>Policy</a:t>
+                        <a:t>Fit on 56%, choose on 19%, report on 25%</a:t>
                       </a:r>
                     </a:p>
                   </a:txBody>
@@ -14338,7 +14948,7 @@
             </a:r>
             <a:r>
               <a:rPr/>
-              <a:t> fix: threads, GPU non-determinism</a:t>
+              <a:t> fix: threads, graphics processing unit (GPU) non-determinism</a:t>
             </a:r>
           </a:p>
         </p:txBody>
@@ -14395,34 +15005,320 @@
           </a:p>
         </p:txBody>
       </p:sp>
-      <p:sp>
-        <p:nvSpPr>
-          <p:cNvPr id="3" name="Content Placeholder 2"/>
-          <p:cNvSpPr>
-            <a:spLocks noGrp="1"/>
-          </p:cNvSpPr>
+      <p:graphicFrame>
+        <p:nvGraphicFramePr>
+          <p:cNvPr id="6" name="Content Placeholder 5"/>
+          <p:cNvGraphicFramePr>
+            <a:graphicFrameLocks noGrp="1"/>
+          </p:cNvGraphicFramePr>
           <p:nvPr>
             <p:ph idx="1"/>
           </p:nvPr>
-        </p:nvSpPr>
-        <p:spPr>
-          <a:xfrm>
-            <a:off x="457200" y="1200151"/>
-            <a:ext cx="8229600" cy="3394472"/>
-          </a:xfrm>
-        </p:spPr>
-        <p:txBody>
-          <a:bodyPr/>
-          <a:lstStyle/>
-          <a:p>
-            <a:pPr lvl="0"/>
-            <a:r>
-              <a:rPr/>
-              <a:t>The 0.931, the fix, the nested search</a:t>
-            </a:r>
-          </a:p>
-        </p:txBody>
-      </p:sp>
+        </p:nvGraphicFramePr>
+        <p:xfrm>
+          <a:off x="457200" y="1166099"/>
+          <a:ext cx="8229600" cy="3390900"/>
+        </p:xfrm>
+        <a:graphic>
+          <a:graphicData uri="http://schemas.openxmlformats.org/drawingml/2006/table">
+            <a:tbl>
+              <a:tblPr firstRow="1" bandRow="1">
+                <a:tableStyleId>{5C22544A-7EE6-4342-B048-85BDC9FD1C3A}</a:tableStyleId>
+              </a:tblPr>
+              <a:tblGrid>
+                <a:gridCol w="4114800"/>
+                <a:gridCol w="4114800"/>
+              </a:tblGrid>
+              <a:tr h="0">
+                <a:tc>
+                  <a:txBody>
+                    <a:bodyPr/>
+                    <a:lstStyle/>
+                    <a:p>
+                      <a:pPr lvl="0" indent="0" marL="0">
+                        <a:buNone/>
+                      </a:pPr>
+                      <a:r>
+                        <a:rPr/>
+                        <a:t>section, and its slides</a:t>
+                      </a:r>
+                    </a:p>
+                  </a:txBody>
+                  <a:tcPr/>
+                </a:tc>
+                <a:tc>
+                  <a:txBody>
+                    <a:bodyPr/>
+                    <a:lstStyle/>
+                    <a:p>
+                      <a:pPr lvl="0" indent="0" marL="0">
+                        <a:buNone/>
+                      </a:pPr>
+                      <a:r>
+                        <a:rPr/>
+                        <a:t>you call (→ the number to come back with)</a:t>
+                      </a:r>
+                    </a:p>
+                  </a:txBody>
+                  <a:tcPr/>
+                </a:tc>
+              </a:tr>
+              <a:tr h="0">
+                <a:tc>
+                  <a:txBody>
+                    <a:bodyPr/>
+                    <a:lstStyle/>
+                    <a:p>
+                      <a:pPr lvl="0" indent="0" marL="0">
+                        <a:buNone/>
+                      </a:pPr>
+                      <a:r>
+                        <a:rPr/>
+                        <a:t>the catastrophe, 32-34</a:t>
+                      </a:r>
+                    </a:p>
+                  </a:txBody>
+                </a:tc>
+                <a:tc>
+                  <a:txBody>
+                    <a:bodyPr/>
+                    <a:lstStyle/>
+                    <a:p>
+                      <a:pPr lvl="0" indent="0" marL="0">
+                        <a:buNone/>
+                      </a:pPr>
+                      <a:r>
+                        <a:rPr>
+                          <a:latin typeface="Courier"/>
+                        </a:rPr>
+                        <a:t>SelectKBest(f_classif, k=10)</a:t>
+                      </a:r>
+                      <a:r>
+                        <a:rPr/>
+                        <a:t> on every row, then </a:t>
+                      </a:r>
+                      <a:r>
+                        <a:rPr>
+                          <a:latin typeface="Courier"/>
+                        </a:rPr>
+                        <a:t>cross_val_score</a:t>
+                      </a:r>
+                      <a:r>
+                        <a:rPr/>
+                        <a:t> → 0.931</a:t>
+                      </a:r>
+                    </a:p>
+                  </a:txBody>
+                </a:tc>
+              </a:tr>
+              <a:tr h="0">
+                <a:tc>
+                  <a:txBody>
+                    <a:bodyPr/>
+                    <a:lstStyle/>
+                    <a:p>
+                      <a:pPr lvl="0" indent="0" marL="0">
+                        <a:buNone/>
+                      </a:pPr>
+                      <a:r>
+                        <a:rPr/>
+                        <a:t>selection inside the fold, 35-36</a:t>
+                      </a:r>
+                    </a:p>
+                  </a:txBody>
+                </a:tc>
+                <a:tc>
+                  <a:txBody>
+                    <a:bodyPr/>
+                    <a:lstStyle/>
+                    <a:p>
+                      <a:pPr lvl="0" indent="0" marL="0">
+                        <a:buNone/>
+                      </a:pPr>
+                      <a:r>
+                        <a:rPr>
+                          <a:latin typeface="Courier"/>
+                        </a:rPr>
+                        <a:t>Pipeline</a:t>
+                      </a:r>
+                      <a:r>
+                        <a:rPr/>
+                        <a:t> with the selector as its first step → 0.658</a:t>
+                      </a:r>
+                    </a:p>
+                  </a:txBody>
+                </a:tc>
+              </a:tr>
+              <a:tr h="0">
+                <a:tc>
+                  <a:txBody>
+                    <a:bodyPr/>
+                    <a:lstStyle/>
+                    <a:p>
+                      <a:pPr lvl="0" indent="0" marL="0">
+                        <a:buNone/>
+                      </a:pPr>
+                      <a:r>
+                        <a:rPr/>
+                        <a:t>the search, 37</a:t>
+                      </a:r>
+                    </a:p>
+                  </a:txBody>
+                </a:tc>
+                <a:tc>
+                  <a:txBody>
+                    <a:bodyPr/>
+                    <a:lstStyle/>
+                    <a:p>
+                      <a:pPr lvl="0" indent="0" marL="0">
+                        <a:buNone/>
+                      </a:pPr>
+                      <a:r>
+                        <a:rPr>
+                          <a:latin typeface="Courier"/>
+                        </a:rPr>
+                        <a:t>GridSearchCV</a:t>
+                      </a:r>
+                      <a:r>
+                        <a:rPr/>
+                        <a:t>, </a:t>
+                      </a:r>
+                      <a:r>
+                        <a:rPr>
+                          <a:latin typeface="Courier"/>
+                        </a:rPr>
+                        <a:t>best_score_</a:t>
+                      </a:r>
+                      <a:r>
+                        <a:rPr/>
+                        <a:t> → 0.7999</a:t>
+                      </a:r>
+                    </a:p>
+                  </a:txBody>
+                </a:tc>
+              </a:tr>
+              <a:tr h="0">
+                <a:tc>
+                  <a:txBody>
+                    <a:bodyPr/>
+                    <a:lstStyle/>
+                    <a:p>
+                      <a:pPr lvl="0" indent="0" marL="0">
+                        <a:buNone/>
+                      </a:pPr>
+                      <a:r>
+                        <a:rPr/>
+                        <a:t>nested, 38-39</a:t>
+                      </a:r>
+                    </a:p>
+                  </a:txBody>
+                </a:tc>
+                <a:tc>
+                  <a:txBody>
+                    <a:bodyPr/>
+                    <a:lstStyle/>
+                    <a:p>
+                      <a:pPr lvl="0" indent="0" marL="0">
+                        <a:buNone/>
+                      </a:pPr>
+                      <a:r>
+                        <a:rPr>
+                          <a:latin typeface="Courier"/>
+                        </a:rPr>
+                        <a:t>cross_val_score(GridSearchCV(...), cv=outer)</a:t>
+                      </a:r>
+                      <a:r>
+                        <a:rPr/>
+                        <a:t> → 0.6699</a:t>
+                      </a:r>
+                    </a:p>
+                  </a:txBody>
+                </a:tc>
+              </a:tr>
+              <a:tr h="0">
+                <a:tc>
+                  <a:txBody>
+                    <a:bodyPr/>
+                    <a:lstStyle/>
+                    <a:p>
+                      <a:pPr lvl="0" indent="0" marL="0">
+                        <a:buNone/>
+                      </a:pPr>
+                      <a:r>
+                        <a:rPr/>
+                        <a:t>the threshold, honestly, 40-41</a:t>
+                      </a:r>
+                    </a:p>
+                  </a:txBody>
+                </a:tc>
+                <a:tc>
+                  <a:txBody>
+                    <a:bodyPr/>
+                    <a:lstStyle/>
+                    <a:p>
+                      <a:pPr lvl="0" indent="0" marL="0">
+                        <a:buNone/>
+                      </a:pPr>
+                      <a:r>
+                        <a:rPr>
+                          <a:latin typeface="Courier"/>
+                        </a:rPr>
+                        <a:t>train_test_split</a:t>
+                      </a:r>
+                      <a:r>
+                        <a:rPr/>
+                        <a:t> twice → 4,700 EUR against 10,540</a:t>
+                      </a:r>
+                    </a:p>
+                  </a:txBody>
+                </a:tc>
+              </a:tr>
+              <a:tr h="0">
+                <a:tc>
+                  <a:txBody>
+                    <a:bodyPr/>
+                    <a:lstStyle/>
+                    <a:p>
+                      <a:pPr lvl="0" indent="0" marL="0">
+                        <a:buNone/>
+                      </a:pPr>
+                      <a:r>
+                        <a:rPr/>
+                        <a:t>seeds, 42-43</a:t>
+                      </a:r>
+                    </a:p>
+                  </a:txBody>
+                </a:tc>
+                <a:tc>
+                  <a:txBody>
+                    <a:bodyPr/>
+                    <a:lstStyle/>
+                    <a:p>
+                      <a:pPr lvl="0" indent="0" marL="0">
+                        <a:buNone/>
+                      </a:pPr>
+                      <a:r>
+                        <a:rPr/>
+                        <a:t>30 values of </a:t>
+                      </a:r>
+                      <a:r>
+                        <a:rPr>
+                          <a:latin typeface="Courier"/>
+                        </a:rPr>
+                        <a:t>random_state</a:t>
+                      </a:r>
+                      <a:r>
+                        <a:rPr/>
+                        <a:t> → 0.913 to 1.000</a:t>
+                      </a:r>
+                    </a:p>
+                  </a:txBody>
+                </a:tc>
+              </a:tr>
+            </a:tbl>
+          </a:graphicData>
+        </a:graphic>
+      </p:graphicFrame>
     </p:spTree>
   </p:cSld>
 </p:sld>
@@ -14960,6 +15856,39 @@
             <a:r>
               <a:rPr/>
               <a:t>Not to exaggerate: 800 rows with 29 positives is the ordinary case</a:t>
+            </a:r>
+          </a:p>
+          <a:p>
+            <a:pPr lvl="0"/>
+            <a:r>
+              <a:rPr/>
+              <a:t>In code: lesson 4’s model, </a:t>
+            </a:r>
+            <a:r>
+              <a:rPr>
+                <a:latin typeface="Courier"/>
+              </a:rPr>
+              <a:t>make_pipeline(StandardScaler(), LogisticRegression())</a:t>
+            </a:r>
+            <a:r>
+              <a:rPr/>
+              <a:t>, on </a:t>
+            </a:r>
+            <a:r>
+              <a:rPr>
+                <a:latin typeface="Courier"/>
+              </a:rPr>
+              <a:t>train_test_split(X, y, test_size=0.25, stratify=y)</a:t>
+            </a:r>
+            <a:r>
+              <a:rPr/>
+              <a:t>, scored by </a:t>
+            </a:r>
+            <a:r>
+              <a:rPr>
+                <a:latin typeface="Courier"/>
+              </a:rPr>
+              <a:t>roc_auc_score</a:t>
             </a:r>
           </a:p>
         </p:txBody>

</xml_diff>